<commit_message>
Deck sd-07-020: slide 3 states only what the lesson says about the fee stack
Co-Authored-By: Claude Sonnet 5.5 <noreply@anthropic.com>
Claude-Session: https://claude.ai/code/session_01C1SaH6cnt22FTK5D8YYaoH
</commit_message>
<xml_diff>
--- a/system-design-101/vi/lessons/sd-07-020/slides/sd-07-020.pptx
+++ b/system-design-101/vi/lessons/sd-07-020/slides/sd-07-020.pptx
@@ -6611,17 +6611,6 @@
               <a:t> thu;</a:t>
             </a:r>
             <a:r>
-              <a:rPr lang="en-US" sz="2400" b="1" dirty="0" spc="-2" kern="0">
-                <a:solidFill>
-                  <a:srgbClr val="14161C"/>
-                </a:solidFill>
-                <a:latin typeface="Be Vietnam Pro" pitchFamily="34" charset="0"/>
-                <a:ea typeface="Be Vietnam Pro" pitchFamily="34" charset="-122"/>
-                <a:cs typeface="Be Vietnam Pro" pitchFamily="34" charset="-120"/>
-              </a:rPr>
-              <a:t> hai</a:t>
-            </a:r>
-            <a:r>
               <a:rPr lang="en-US" sz="2400" b="1" dirty="0" spc="-3" kern="0">
                 <a:solidFill>
                   <a:srgbClr val="14161C"/>
@@ -6630,62 +6619,95 @@
                 <a:ea typeface="Be Vietnam Pro" pitchFamily="34" charset="-122"/>
                 <a:cs typeface="Be Vietnam Pro" pitchFamily="34" charset="-120"/>
               </a:rPr>
+              <a:t> khoản</a:t>
+            </a:r>
+            <a:r>
+              <a:rPr lang="en-US" sz="2400" b="1" dirty="0" spc="-11" kern="0">
+                <a:solidFill>
+                  <a:srgbClr val="14161C"/>
+                </a:solidFill>
+                <a:latin typeface="Be Vietnam Pro" pitchFamily="34" charset="0"/>
+                <a:ea typeface="Be Vietnam Pro" pitchFamily="34" charset="-122"/>
+                <a:cs typeface="Be Vietnam Pro" pitchFamily="34" charset="-120"/>
+              </a:rPr>
+              <a:t> này</a:t>
+            </a:r>
+            <a:r>
+              <a:rPr lang="en-US" sz="2400" b="1" dirty="0" spc="-3" kern="0">
+                <a:solidFill>
+                  <a:srgbClr val="14161C"/>
+                </a:solidFill>
+                <a:latin typeface="Be Vietnam Pro" pitchFamily="34" charset="0"/>
+                <a:ea typeface="Be Vietnam Pro" pitchFamily="34" charset="-122"/>
+                <a:cs typeface="Be Vietnam Pro" pitchFamily="34" charset="-120"/>
+              </a:rPr>
+              <a:t> phải</a:t>
+            </a:r>
+            <a:r>
+              <a:rPr lang="en-US" sz="2400" b="1" dirty="0" spc="3" kern="0">
+                <a:solidFill>
+                  <a:srgbClr val="14161C"/>
+                </a:solidFill>
+                <a:latin typeface="Be Vietnam Pro" pitchFamily="34" charset="0"/>
+                <a:ea typeface="Be Vietnam Pro" pitchFamily="34" charset="-122"/>
+                <a:cs typeface="Be Vietnam Pro" pitchFamily="34" charset="-120"/>
+              </a:rPr>
+              <a:t> đủ</a:t>
+            </a:r>
+            <a:r>
+              <a:rPr lang="en-US" sz="2400" b="1" dirty="0" spc="4" kern="0">
+                <a:solidFill>
+                  <a:srgbClr val="14161C"/>
+                </a:solidFill>
+                <a:latin typeface="Be Vietnam Pro" pitchFamily="34" charset="0"/>
+                <a:ea typeface="Be Vietnam Pro" pitchFamily="34" charset="-122"/>
+                <a:cs typeface="Be Vietnam Pro" pitchFamily="34" charset="-120"/>
+              </a:rPr>
+              <a:t> bù</a:t>
+            </a:r>
+            <a:r>
+              <a:rPr lang="en-US" sz="2400" b="1" dirty="0" spc="-3" kern="0">
+                <a:solidFill>
+                  <a:srgbClr val="14161C"/>
+                </a:solidFill>
+                <a:latin typeface="Be Vietnam Pro" pitchFamily="34" charset="0"/>
+                <a:ea typeface="Be Vietnam Pro" pitchFamily="34" charset="-122"/>
+                <a:cs typeface="Be Vietnam Pro" pitchFamily="34" charset="-120"/>
+              </a:rPr>
               <a:t> phí</a:t>
             </a:r>
             <a:r>
-              <a:rPr lang="en-US" sz="2400" b="1" dirty="0" spc="1" kern="0">
-                <a:solidFill>
-                  <a:srgbClr val="14161C"/>
-                </a:solidFill>
-                <a:latin typeface="Be Vietnam Pro" pitchFamily="34" charset="0"/>
-                <a:ea typeface="Be Vietnam Pro" pitchFamily="34" charset="-122"/>
-                <a:cs typeface="Be Vietnam Pro" pitchFamily="34" charset="-120"/>
-              </a:rPr>
-              <a:t> kia</a:t>
-            </a:r>
-            <a:r>
-              <a:rPr lang="en-US" sz="2400" b="1" dirty="0" spc="-1" kern="0">
-                <a:solidFill>
-                  <a:srgbClr val="14161C"/>
-                </a:solidFill>
-                <a:latin typeface="Be Vietnam Pro" pitchFamily="34" charset="0"/>
-                <a:ea typeface="Be Vietnam Pro" pitchFamily="34" charset="-122"/>
-                <a:cs typeface="Be Vietnam Pro" pitchFamily="34" charset="-120"/>
-              </a:rPr>
-              <a:t> nằm</a:t>
-            </a:r>
-            <a:r>
-              <a:rPr lang="en-US" sz="2400" b="1" dirty="0" spc="-13" kern="0">
-                <a:solidFill>
-                  <a:srgbClr val="14161C"/>
-                </a:solidFill>
-                <a:latin typeface="Be Vietnam Pro" pitchFamily="34" charset="0"/>
-                <a:ea typeface="Be Vietnam Pro" pitchFamily="34" charset="-122"/>
-                <a:cs typeface="Be Vietnam Pro" pitchFamily="34" charset="-120"/>
-              </a:rPr>
-              <a:t> trên</a:t>
-            </a:r>
-            <a:r>
-              <a:rPr lang="en-US" sz="2400" b="1" dirty="0" spc="-2" kern="0">
-                <a:solidFill>
-                  <a:srgbClr val="14161C"/>
-                </a:solidFill>
-                <a:latin typeface="Be Vietnam Pro" pitchFamily="34" charset="0"/>
-                <a:ea typeface="Be Vietnam Pro" pitchFamily="34" charset="-122"/>
-                <a:cs typeface="Be Vietnam Pro" pitchFamily="34" charset="-120"/>
-              </a:rPr>
-              <a:t> khoản</a:t>
-            </a:r>
-            <a:r>
-              <a:rPr lang="en-US" sz="2400" b="1" dirty="0" spc="-9" kern="0">
-                <a:solidFill>
-                  <a:srgbClr val="14161C"/>
-                </a:solidFill>
-                <a:latin typeface="Be Vietnam Pro" pitchFamily="34" charset="0"/>
-                <a:ea typeface="Be Vietnam Pro" pitchFamily="34" charset="-122"/>
-                <a:cs typeface="Be Vietnam Pro" pitchFamily="34" charset="-120"/>
-              </a:rPr>
-              <a:t> này.</a:t>
+              <a:rPr lang="en-US" sz="2400" b="1" dirty="0" spc="-4" kern="0">
+                <a:solidFill>
+                  <a:srgbClr val="14161C"/>
+                </a:solidFill>
+                <a:latin typeface="Be Vietnam Pro" pitchFamily="34" charset="0"/>
+                <a:ea typeface="Be Vietnam Pro" pitchFamily="34" charset="-122"/>
+                <a:cs typeface="Be Vietnam Pro" pitchFamily="34" charset="-120"/>
+              </a:rPr>
+              <a:t> liên</a:t>
+            </a:r>
+            <a:r>
+              <a:rPr lang="en-US" sz="2400" b="1" dirty="0" spc="-6" kern="0">
+                <a:solidFill>
+                  <a:srgbClr val="14161C"/>
+                </a:solidFill>
+                <a:latin typeface="Be Vietnam Pro" pitchFamily="34" charset="0"/>
+                <a:ea typeface="Be Vietnam Pro" pitchFamily="34" charset="-122"/>
+                <a:cs typeface="Be Vietnam Pro" pitchFamily="34" charset="-120"/>
+              </a:rPr>
+              <a:t> ngân</a:t>
+            </a:r>
+            <a:r>
+              <a:rPr lang="en-US" sz="2400" b="1" dirty="0" spc="-4" kern="0">
+                <a:solidFill>
+                  <a:srgbClr val="14161C"/>
+                </a:solidFill>
+                <a:latin typeface="Be Vietnam Pro" pitchFamily="34" charset="0"/>
+                <a:ea typeface="Be Vietnam Pro" pitchFamily="34" charset="-122"/>
+                <a:cs typeface="Be Vietnam Pro" pitchFamily="34" charset="-120"/>
+              </a:rPr>
+              <a:t> hàng.</a:t>
             </a:r>
             <a:endParaRPr lang="en-US" sz="2400" dirty="0"/>
           </a:p>

</xml_diff>

<commit_message>
Lesson, figure and deck sd-07-020: the issuer funds the merchant side through the network and acquirer
Co-Authored-By: Claude Sonnet 5.5 <noreply@anthropic.com>
Claude-Session: https://claude.ai/code/session_01C1SaH6cnt22FTK5D8YYaoH
</commit_message>
<xml_diff>
--- a/system-design-101/vi/lessons/sd-07-020/slides/sd-07-020.pptx
+++ b/system-design-101/vi/lessons/sd-07-020/slides/sd-07-020.pptx
@@ -10221,26 +10221,81 @@
               <a:buNone/>
             </a:pPr>
             <a:r>
-              <a:rPr lang="en-US" sz="2550" b="1" dirty="0" spc="-64" kern="0">
-                <a:solidFill>
-                  <a:srgbClr val="14161C"/>
-                </a:solidFill>
-                <a:latin typeface="Be Vietnam Pro" pitchFamily="34" charset="0"/>
-                <a:ea typeface="Be Vietnam Pro" pitchFamily="34" charset="-122"/>
-                <a:cs typeface="Be Vietnam Pro" pitchFamily="34" charset="-120"/>
-              </a:rPr>
-              <a:t>Trả</a:t>
-            </a:r>
-            <a:r>
-              <a:rPr lang="en-US" sz="2550" b="1" dirty="0" spc="12" kern="0">
-                <a:solidFill>
-                  <a:srgbClr val="14161C"/>
-                </a:solidFill>
-                <a:latin typeface="Be Vietnam Pro" pitchFamily="34" charset="0"/>
-                <a:ea typeface="Be Vietnam Pro" pitchFamily="34" charset="-122"/>
-                <a:cs typeface="Be Vietnam Pro" pitchFamily="34" charset="-120"/>
-              </a:rPr>
-              <a:t> người</a:t>
+              <a:rPr lang="en-US" sz="2550" b="1" dirty="0" spc="-16" kern="0">
+                <a:solidFill>
+                  <a:srgbClr val="14161C"/>
+                </a:solidFill>
+                <a:latin typeface="Be Vietnam Pro" pitchFamily="34" charset="0"/>
+                <a:ea typeface="Be Vietnam Pro" pitchFamily="34" charset="-122"/>
+                <a:cs typeface="Be Vietnam Pro" pitchFamily="34" charset="-120"/>
+              </a:rPr>
+              <a:t>Chuyển</a:t>
+            </a:r>
+            <a:r>
+              <a:rPr lang="en-US" sz="2550" b="1" dirty="0" spc="-2" kern="0">
+                <a:solidFill>
+                  <a:srgbClr val="14161C"/>
+                </a:solidFill>
+                <a:latin typeface="Be Vietnam Pro" pitchFamily="34" charset="0"/>
+                <a:ea typeface="Be Vietnam Pro" pitchFamily="34" charset="-122"/>
+                <a:cs typeface="Be Vietnam Pro" pitchFamily="34" charset="-120"/>
+              </a:rPr>
+              <a:t> tiền</a:t>
+            </a:r>
+            <a:r>
+              <a:rPr lang="en-US" sz="2550" b="1" dirty="0" spc="2" kern="0">
+                <a:solidFill>
+                  <a:srgbClr val="14161C"/>
+                </a:solidFill>
+                <a:latin typeface="Be Vietnam Pro" pitchFamily="34" charset="0"/>
+                <a:ea typeface="Be Vietnam Pro" pitchFamily="34" charset="-122"/>
+                <a:cs typeface="Be Vietnam Pro" pitchFamily="34" charset="-120"/>
+              </a:rPr>
+              <a:t> (qua</a:t>
+            </a:r>
+            <a:r>
+              <a:rPr lang="en-US" sz="2550" b="1" dirty="0" spc="-4" kern="0">
+                <a:solidFill>
+                  <a:srgbClr val="14161C"/>
+                </a:solidFill>
+                <a:latin typeface="Be Vietnam Pro" pitchFamily="34" charset="0"/>
+                <a:ea typeface="Be Vietnam Pro" pitchFamily="34" charset="-122"/>
+                <a:cs typeface="Be Vietnam Pro" pitchFamily="34" charset="-120"/>
+              </a:rPr>
+              <a:t> ngân</a:t>
+            </a:r>
+            <a:r>
+              <a:rPr lang="en-US" sz="2550" b="1" dirty="0" spc="-3" kern="0">
+                <a:solidFill>
+                  <a:srgbClr val="14161C"/>
+                </a:solidFill>
+                <a:latin typeface="Be Vietnam Pro" pitchFamily="34" charset="0"/>
+                <a:ea typeface="Be Vietnam Pro" pitchFamily="34" charset="-122"/>
+                <a:cs typeface="Be Vietnam Pro" pitchFamily="34" charset="-120"/>
+              </a:rPr>
+              <a:t> hàng</a:t>
+            </a:r>
+            <a:r>
+              <a:rPr lang="en-US" sz="2550" b="1" dirty="0" spc="2" kern="0">
+                <a:solidFill>
+                  <a:srgbClr val="14161C"/>
+                </a:solidFill>
+                <a:latin typeface="Be Vietnam Pro" pitchFamily="34" charset="0"/>
+                <a:ea typeface="Be Vietnam Pro" pitchFamily="34" charset="-122"/>
+                <a:cs typeface="Be Vietnam Pro" pitchFamily="34" charset="-120"/>
+              </a:rPr>
+              <a:t> thu)</a:t>
+            </a:r>
+            <a:r>
+              <a:rPr lang="en-US" sz="2550" b="1" dirty="0" spc="-1" kern="0">
+                <a:solidFill>
+                  <a:srgbClr val="14161C"/>
+                </a:solidFill>
+                <a:latin typeface="Be Vietnam Pro" pitchFamily="34" charset="0"/>
+                <a:ea typeface="Be Vietnam Pro" pitchFamily="34" charset="-122"/>
+                <a:cs typeface="Be Vietnam Pro" pitchFamily="34" charset="-120"/>
+              </a:rPr>
+              <a:t> dù</a:t>
             </a:r>
             <a:r>
               <a:rPr lang="en-US" sz="2550" b="1" dirty="0" spc="0" kern="0">
@@ -10251,21 +10306,10 @@
                 <a:ea typeface="Be Vietnam Pro" pitchFamily="34" charset="-122"/>
                 <a:cs typeface="Be Vietnam Pro" pitchFamily="34" charset="-120"/>
               </a:rPr>
-              <a:t> bán</a:t>
-            </a:r>
-            <a:r>
-              <a:rPr lang="en-US" sz="2550" b="1" dirty="0" spc="-1" kern="0">
-                <a:solidFill>
-                  <a:srgbClr val="14161C"/>
-                </a:solidFill>
-                <a:latin typeface="Be Vietnam Pro" pitchFamily="34" charset="0"/>
-                <a:ea typeface="Be Vietnam Pro" pitchFamily="34" charset="-122"/>
-                <a:cs typeface="Be Vietnam Pro" pitchFamily="34" charset="-120"/>
-              </a:rPr>
-              <a:t> dù chủ</a:t>
-            </a:r>
-            <a:r>
-              <a:rPr lang="en-US" sz="2550" b="1" dirty="0" spc="-2" kern="0">
+              <a:t> chủ</a:t>
+            </a:r>
+            <a:r>
+              <a:rPr lang="en-US" sz="2550" b="1" dirty="0" spc="-3" kern="0">
                 <a:solidFill>
                   <a:srgbClr val="14161C"/>
                 </a:solidFill>
@@ -10287,7 +10331,7 @@
               <a:t> không</a:t>
             </a:r>
             <a:r>
-              <a:rPr lang="en-US" sz="2550" b="1" dirty="0" spc="-11" kern="0">
+              <a:rPr lang="en-US" sz="2550" b="1" dirty="0" spc="-10" kern="0">
                 <a:solidFill>
                   <a:srgbClr val="14161C"/>
                 </a:solidFill>
@@ -10396,40 +10440,29 @@
               <a:buNone/>
             </a:pPr>
             <a:r>
-              <a:rPr lang="en-US" sz="2550" b="1" dirty="0" spc="-64" kern="0">
-                <a:solidFill>
-                  <a:srgbClr val="14161C"/>
-                </a:solidFill>
-                <a:latin typeface="Be Vietnam Pro" pitchFamily="34" charset="0"/>
-                <a:ea typeface="Be Vietnam Pro" pitchFamily="34" charset="-122"/>
-                <a:cs typeface="Be Vietnam Pro" pitchFamily="34" charset="-120"/>
-              </a:rPr>
-              <a:t>Trả</a:t>
-            </a:r>
-            <a:r>
-              <a:rPr lang="en-US" sz="2550" b="1" dirty="0" spc="12" kern="0">
-                <a:solidFill>
-                  <a:srgbClr val="14161C"/>
-                </a:solidFill>
-                <a:latin typeface="Be Vietnam Pro" pitchFamily="34" charset="0"/>
-                <a:ea typeface="Be Vietnam Pro" pitchFamily="34" charset="-122"/>
-                <a:cs typeface="Be Vietnam Pro" pitchFamily="34" charset="-120"/>
-              </a:rPr>
-              <a:t> người</a:t>
-            </a:r>
-            <a:r>
-              <a:rPr lang="en-US" sz="2550" b="1" dirty="0" spc="0" kern="0">
-                <a:solidFill>
-                  <a:srgbClr val="14161C"/>
-                </a:solidFill>
-                <a:latin typeface="Be Vietnam Pro" pitchFamily="34" charset="0"/>
-                <a:ea typeface="Be Vietnam Pro" pitchFamily="34" charset="-122"/>
-                <a:cs typeface="Be Vietnam Pro" pitchFamily="34" charset="-120"/>
-              </a:rPr>
-              <a:t> bán</a:t>
-            </a:r>
-            <a:r>
-              <a:rPr lang="en-US" sz="2550" b="1" dirty="0" spc="9" kern="0">
+              <a:rPr lang="en-US" sz="2550" b="1" dirty="0" spc="-16" kern="0">
+                <a:solidFill>
+                  <a:srgbClr val="14161C"/>
+                </a:solidFill>
+                <a:latin typeface="Be Vietnam Pro" pitchFamily="34" charset="0"/>
+                <a:ea typeface="Be Vietnam Pro" pitchFamily="34" charset="-122"/>
+                <a:cs typeface="Be Vietnam Pro" pitchFamily="34" charset="-120"/>
+              </a:rPr>
+              <a:t>Chuyển</a:t>
+            </a:r>
+            <a:r>
+              <a:rPr lang="en-US" sz="2550" b="1" dirty="0" spc="-2" kern="0">
+                <a:solidFill>
+                  <a:srgbClr val="14161C"/>
+                </a:solidFill>
+                <a:latin typeface="Be Vietnam Pro" pitchFamily="34" charset="0"/>
+                <a:ea typeface="Be Vietnam Pro" pitchFamily="34" charset="-122"/>
+                <a:cs typeface="Be Vietnam Pro" pitchFamily="34" charset="-120"/>
+              </a:rPr>
+              <a:t> tiền</a:t>
+            </a:r>
+            <a:r>
+              <a:rPr lang="en-US" sz="2550" b="1" dirty="0" spc="10" kern="0">
                 <a:solidFill>
                   <a:srgbClr val="14161C"/>
                 </a:solidFill>

</xml_diff>